<commit_message>
Pitch deck: Proprietary Convergence Protocol (PCP)
Co-Authored-By: Claude Opus 5.5 <noreply@anthropic.com>
</commit_message>
<xml_diff>
--- a/assets/Wrexlyn-Pitch-Deck.pptx
+++ b/assets/Wrexlyn-Pitch-Deck.pptx
@@ -18399,7 +18399,7 @@
                 <a:ea typeface="Calibri" pitchFamily="34" charset="-122"/>
                 <a:cs typeface="Calibri" pitchFamily="34" charset="-120"/>
               </a:rPr>
-              <a:t>THE NISHANT CONVERGENCE PROTOCOL</a:t>
+              <a:t>THE PROPRIETARY CONVERGENCE PROTOCOL</a:t>
             </a:r>
             <a:endParaRPr lang="en-US" sz="1100" dirty="0"/>
           </a:p>
@@ -18480,7 +18480,7 @@
                 <a:ea typeface="Calibri" pitchFamily="34" charset="-122"/>
                 <a:cs typeface="Calibri" pitchFamily="34" charset="-120"/>
               </a:rPr>
-              <a:t>A weak model is rarely bad at a first attempt — it’s bad at self-correcting once that attempt fails. NCP formalizes the fix as a named, versioned, unit-tested algorithm, invoked only once a plain repair has already failed once.</a:t>
+              <a:t>A weak model is rarely bad at a first attempt — it’s bad at self-correcting once that attempt fails. PCP formalizes the fix as a named, versioned, unit-tested algorithm, invoked only once a plain repair has already failed once.</a:t>
             </a:r>
             <a:endParaRPr lang="en-US" sz="1450" dirty="0"/>
           </a:p>
@@ -19217,7 +19217,7 @@
                 <a:ea typeface="Calibri" pitchFamily="34" charset="-122"/>
                 <a:cs typeface="Calibri" pitchFamily="34" charset="-120"/>
               </a:rPr>
-              <a:t> NCP does not make a small model reason like a large one. It closes the reliability gap on tasks with an external check — not a claim of raw intelligence uplift.</a:t>
+              <a:t> PCP does not make a small model reason like a large one. It closes the reliability gap on tasks with an external check — not a claim of raw intelligence uplift.</a:t>
             </a:r>
             <a:endParaRPr lang="en-US" sz="1150" dirty="0"/>
           </a:p>
@@ -29171,7 +29171,7 @@
                 <a:ea typeface="Calibri" pitchFamily="34" charset="-122"/>
                 <a:cs typeface="Calibri" pitchFamily="34" charset="-120"/>
               </a:rPr>
-              <a:t>“The reliability runtime,” “the document quality gate,” “the Nishant Convergence Protocol” are specific, citable names for specific code — not a marketing umbrella over whatever the model happened to do that day.</a:t>
+              <a:t>“The reliability runtime,” “the document quality gate,” “the Proprietary Convergence Protocol” are specific, citable names for specific code — not a marketing umbrella over whatever the model happened to do that day.</a:t>
             </a:r>
             <a:endParaRPr lang="en-US" sz="1050" dirty="0"/>
           </a:p>
@@ -33321,7 +33321,7 @@
                 <a:ea typeface="Calibri" pitchFamily="34" charset="-122"/>
                 <a:cs typeface="Calibri" pitchFamily="34" charset="-120"/>
               </a:rPr>
-              <a:t>Independent critique, bounded repair, recurrence detection and NCP replace infinite, uninformed retries.</a:t>
+              <a:t>Independent critique, bounded repair, recurrence detection and PCP replace infinite, uninformed retries.</a:t>
             </a:r>
             <a:endParaRPr lang="en-US" sz="1050" dirty="0"/>
           </a:p>

</xml_diff>